<commit_message>
feat: atualizacao da apresentacao e inclusao de pdf
</commit_message>
<xml_diff>
--- a/slides/apresentacao_house_prices_c3.pptx
+++ b/slides/apresentacao_house_prices_c3.pptx
@@ -17,8 +17,8 @@
     <p:sldId id="262" r:id="rId8"/>
     <p:sldId id="263" r:id="rId9"/>
     <p:sldId id="264" r:id="rId10"/>
-    <p:sldId id="265" r:id="rId11"/>
-    <p:sldId id="266" r:id="rId12"/>
+    <p:sldId id="266" r:id="rId11"/>
+    <p:sldId id="269" r:id="rId12"/>
     <p:sldId id="267" r:id="rId13"/>
     <p:sldId id="268" r:id="rId14"/>
   </p:sldIdLst>
@@ -119,6 +119,11 @@
       </a:defRPr>
     </a:lvl9pPr>
   </p:defaultTextStyle>
+  <p:extLst>
+    <p:ext uri="{EFAFB233-063F-42B5-8137-9DF3F51BA10A}">
+      <p15:sldGuideLst xmlns:p15="http://schemas.microsoft.com/office/powerpoint/2012/main"/>
+    </p:ext>
+  </p:extLst>
 </p:presentation>
 </file>
 
@@ -604,7 +609,7 @@
           <a:p>
             <a:r>
               <a:rPr lang="pt-BR"/>
-              <a:t>Natalia: explicar que esse slide responde diretamente ao feedback da avaliação: faltavam gráficos dos modelos no notebook 06.</a:t>
+              <a:t>Natalia: reforçar que visualização é usada para guiar o leitor, não apenas ilustrar.</a:t>
             </a:r>
           </a:p>
         </p:txBody>
@@ -635,7 +640,7 @@
     </p:spTree>
     <p:extLst>
       <p:ext uri="{BB962C8B-B14F-4D97-AF65-F5344CB8AC3E}">
-        <p14:creationId xmlns:p14="http://schemas.microsoft.com/office/powerpoint/2010/main" val="4048604703"/>
+        <p14:creationId xmlns:p14="http://schemas.microsoft.com/office/powerpoint/2010/main" val="2206641937"/>
       </p:ext>
     </p:extLst>
   </p:cSld>
@@ -650,7 +655,13 @@
   <p:cSld>
     <p:spTree>
       <p:nvGrpSpPr>
-        <p:cNvPr id="1" name=""/>
+        <p:cNvPr id="1" name="">
+          <a:extLst>
+            <a:ext uri="{FF2B5EF4-FFF2-40B4-BE49-F238E27FC236}">
+              <a16:creationId xmlns:a16="http://schemas.microsoft.com/office/drawing/2014/main" id="{A08AA723-A32B-82EA-ABF3-42B54D06AF57}"/>
+            </a:ext>
+          </a:extLst>
+        </p:cNvPr>
         <p:cNvGrpSpPr/>
         <p:nvPr/>
       </p:nvGrpSpPr>
@@ -664,7 +675,13 @@
       </p:grpSpPr>
       <p:sp>
         <p:nvSpPr>
-          <p:cNvPr id="2" name="Espaço Reservado para Imagem de Slide 1"/>
+          <p:cNvPr id="2" name="Espaço Reservado para Imagem de Slide 1">
+            <a:extLst>
+              <a:ext uri="{FF2B5EF4-FFF2-40B4-BE49-F238E27FC236}">
+                <a16:creationId xmlns:a16="http://schemas.microsoft.com/office/drawing/2014/main" id="{8F59AA70-C9CD-25EA-DAC3-5DE62C4CE7C5}"/>
+              </a:ext>
+            </a:extLst>
+          </p:cNvPr>
           <p:cNvSpPr>
             <a:spLocks noGrp="1" noRot="1" noChangeAspect="1"/>
           </p:cNvSpPr>
@@ -676,7 +693,13 @@
       </p:sp>
       <p:sp>
         <p:nvSpPr>
-          <p:cNvPr id="3" name="Espaço Reservado para Anotações 2"/>
+          <p:cNvPr id="3" name="Espaço Reservado para Anotações 2">
+            <a:extLst>
+              <a:ext uri="{FF2B5EF4-FFF2-40B4-BE49-F238E27FC236}">
+                <a16:creationId xmlns:a16="http://schemas.microsoft.com/office/drawing/2014/main" id="{DEF80783-20D6-A56B-520E-682178AAE4C0}"/>
+              </a:ext>
+            </a:extLst>
+          </p:cNvPr>
           <p:cNvSpPr>
             <a:spLocks noGrp="1"/>
           </p:cNvSpPr>
@@ -691,14 +714,20 @@
           <a:p>
             <a:r>
               <a:rPr lang="pt-BR"/>
-              <a:t>Natalia: reforçar que visualização é usada para guiar o leitor, não apenas ilustrar.</a:t>
-            </a:r>
-          </a:p>
-        </p:txBody>
-      </p:sp>
-      <p:sp>
-        <p:nvSpPr>
-          <p:cNvPr id="4" name="Espaço Reservado para Número de Slide 3"/>
+              <a:t>Natalia: explicar que esse slide responde diretamente ao feedback da avaliação: faltavam gráficos dos modelos no notebook 06.</a:t>
+            </a:r>
+          </a:p>
+        </p:txBody>
+      </p:sp>
+      <p:sp>
+        <p:nvSpPr>
+          <p:cNvPr id="4" name="Espaço Reservado para Número de Slide 3">
+            <a:extLst>
+              <a:ext uri="{FF2B5EF4-FFF2-40B4-BE49-F238E27FC236}">
+                <a16:creationId xmlns:a16="http://schemas.microsoft.com/office/drawing/2014/main" id="{751BF492-2EEF-7B04-A9AB-6672AEF09B6C}"/>
+              </a:ext>
+            </a:extLst>
+          </p:cNvPr>
           <p:cNvSpPr>
             <a:spLocks noGrp="1"/>
           </p:cNvSpPr>
@@ -722,7 +751,7 @@
     </p:spTree>
     <p:extLst>
       <p:ext uri="{BB962C8B-B14F-4D97-AF65-F5344CB8AC3E}">
-        <p14:creationId xmlns:p14="http://schemas.microsoft.com/office/powerpoint/2010/main" val="2206641937"/>
+        <p14:creationId xmlns:p14="http://schemas.microsoft.com/office/powerpoint/2010/main" val="809457441"/>
       </p:ext>
     </p:extLst>
   </p:cSld>
@@ -5034,7 +5063,7 @@
         </p:nvSpPr>
         <p:spPr>
           <a:xfrm>
-            <a:off x="1333500" y="3302000"/>
+            <a:off x="1333500" y="3213715"/>
             <a:ext cx="2286000" cy="1117600"/>
           </a:xfrm>
           <a:prstGeom prst="rect">
@@ -5170,7 +5199,7 @@
         </p:nvSpPr>
         <p:spPr>
           <a:xfrm>
-            <a:off x="3810000" y="3302000"/>
+            <a:off x="3810000" y="3213715"/>
             <a:ext cx="2286000" cy="1117600"/>
           </a:xfrm>
           <a:prstGeom prst="rect">
@@ -5306,7 +5335,7 @@
         </p:nvSpPr>
         <p:spPr>
           <a:xfrm>
-            <a:off x="6286500" y="3302000"/>
+            <a:off x="6286500" y="3213715"/>
             <a:ext cx="2286000" cy="1117600"/>
           </a:xfrm>
           <a:prstGeom prst="rect">
@@ -5442,7 +5471,7 @@
         </p:nvSpPr>
         <p:spPr>
           <a:xfrm>
-            <a:off x="8763000" y="3302000"/>
+            <a:off x="8763000" y="3213715"/>
             <a:ext cx="2286000" cy="1117600"/>
           </a:xfrm>
           <a:prstGeom prst="rect">
@@ -5648,7 +5677,7 @@
           <p:cNvPr id="2" name="Retângulo 1">
             <a:extLst>
               <a:ext uri="{FF2B5EF4-FFF2-40B4-BE49-F238E27FC236}">
-                <a16:creationId xmlns:a16="http://schemas.microsoft.com/office/drawing/2014/main" id="{9689A4C5-9ABE-BFE9-132A-102C92C5ECF5}"/>
+                <a16:creationId xmlns:a16="http://schemas.microsoft.com/office/drawing/2014/main" id="{B6D25A27-2BDF-148A-8D85-5C41DECE5B79}"/>
               </a:ext>
             </a:extLst>
           </p:cNvPr>
@@ -5716,7 +5745,7 @@
           <p:cNvPr id="3" name="CaixaDeTexto 2">
             <a:extLst>
               <a:ext uri="{FF2B5EF4-FFF2-40B4-BE49-F238E27FC236}">
-                <a16:creationId xmlns:a16="http://schemas.microsoft.com/office/drawing/2014/main" id="{AFF1B0FE-AE5A-9E1B-3737-175EF100EB2F}"/>
+                <a16:creationId xmlns:a16="http://schemas.microsoft.com/office/drawing/2014/main" id="{0C96A9D2-C4C1-758C-105B-F92F8FB0A442}"/>
               </a:ext>
             </a:extLst>
           </p:cNvPr>
@@ -5740,14 +5769,29 @@
           <a:lstStyle/>
           <a:p>
             <a:r>
-              <a:rPr lang="pt-BR" sz="2400" b="1">
+              <a:rPr lang="pt-BR" sz="2400" b="1" dirty="0">
                 <a:solidFill>
                   <a:srgbClr val="FFFFFF"/>
                 </a:solidFill>
                 <a:latin typeface="Aptos" panose="020B0004020202020204" pitchFamily="34" charset="0"/>
               </a:rPr>
-              <a:t>Notebook 06: Resultados Consolidados</a:t>
-            </a:r>
+              <a:t>Visualização e </a:t>
+            </a:r>
+            <a:r>
+              <a:rPr lang="pt-BR" sz="2400" b="1" dirty="0" err="1">
+                <a:solidFill>
+                  <a:srgbClr val="FFFFFF"/>
+                </a:solidFill>
+                <a:latin typeface="Aptos" panose="020B0004020202020204" pitchFamily="34" charset="0"/>
+              </a:rPr>
+              <a:t>Storytelling</a:t>
+            </a:r>
+            <a:endParaRPr lang="pt-BR" sz="2400" b="1" dirty="0">
+              <a:solidFill>
+                <a:srgbClr val="FFFFFF"/>
+              </a:solidFill>
+              <a:latin typeface="Aptos" panose="020B0004020202020204" pitchFamily="34" charset="0"/>
+            </a:endParaRPr>
           </a:p>
         </p:txBody>
       </p:sp>
@@ -5756,7 +5800,7 @@
           <p:cNvPr id="4" name="CaixaDeTexto 3">
             <a:extLst>
               <a:ext uri="{FF2B5EF4-FFF2-40B4-BE49-F238E27FC236}">
-                <a16:creationId xmlns:a16="http://schemas.microsoft.com/office/drawing/2014/main" id="{3EDC3378-647B-E7C4-A12A-6266A964B90F}"/>
+                <a16:creationId xmlns:a16="http://schemas.microsoft.com/office/drawing/2014/main" id="{96ADCF12-1C7F-9EB1-38B7-500B90DE0DE0}"/>
               </a:ext>
             </a:extLst>
           </p:cNvPr>
@@ -5794,10 +5838,10 @@
       </p:sp>
       <p:sp>
         <p:nvSpPr>
-          <p:cNvPr id="5" name="CaixaDeTexto 4">
-            <a:extLst>
-              <a:ext uri="{FF2B5EF4-FFF2-40B4-BE49-F238E27FC236}">
-                <a16:creationId xmlns:a16="http://schemas.microsoft.com/office/drawing/2014/main" id="{C1DB72EC-6131-A713-E0DB-B29CE4691885}"/>
+          <p:cNvPr id="8" name="CaixaDeTexto 7">
+            <a:extLst>
+              <a:ext uri="{FF2B5EF4-FFF2-40B4-BE49-F238E27FC236}">
+                <a16:creationId xmlns:a16="http://schemas.microsoft.com/office/drawing/2014/main" id="{39C760CB-6477-A97E-844E-FC4EA9A83AFF}"/>
               </a:ext>
             </a:extLst>
           </p:cNvPr>
@@ -5806,8 +5850,8 @@
         </p:nvSpPr>
         <p:spPr>
           <a:xfrm>
-            <a:off x="685800" y="1168400"/>
-            <a:ext cx="4445000" cy="3180358"/>
+            <a:off x="833597" y="940707"/>
+            <a:ext cx="10524805" cy="328295"/>
           </a:xfrm>
           <a:prstGeom prst="rect">
             <a:avLst/>
@@ -5815,108 +5859,30 @@
           <a:noFill/>
         </p:spPr>
         <p:txBody>
-          <a:bodyPr vert="horz" lIns="50800" tIns="25400" rIns="50800" bIns="25400" rtlCol="0">
+          <a:bodyPr vert="horz" wrap="square" lIns="50800" tIns="25400" rIns="50800" bIns="25400" rtlCol="0">
             <a:spAutoFit/>
           </a:bodyPr>
           <a:lstStyle/>
           <a:p>
-            <a:pPr marL="342900" indent="-342900">
-              <a:spcAft>
-                <a:spcPts val="700"/>
-              </a:spcAft>
-              <a:buFont typeface="+mj-lt"/>
-              <a:buChar char="•"/>
-            </a:pPr>
-            <a:r>
-              <a:rPr lang="pt-BR">
-                <a:solidFill>
-                  <a:srgbClr val="1E2227"/>
+            <a:pPr algn="ctr"/>
+            <a:r>
+              <a:rPr lang="pt-BR" b="1" dirty="0">
+                <a:solidFill>
+                  <a:srgbClr val="162B3A"/>
                 </a:solidFill>
                 <a:latin typeface="Aptos" panose="020B0004020202020204" pitchFamily="34" charset="0"/>
               </a:rPr>
-              <a:t>Nova seção reúne os resultados dos modelos em painéis visuais</a:t>
-            </a:r>
-          </a:p>
-          <a:p>
-            <a:pPr marL="342900" indent="-342900">
-              <a:spcAft>
-                <a:spcPts val="700"/>
-              </a:spcAft>
-              <a:buFont typeface="+mj-lt"/>
-              <a:buChar char="•"/>
-            </a:pPr>
-            <a:r>
-              <a:rPr lang="pt-BR">
-                <a:solidFill>
-                  <a:srgbClr val="1E2227"/>
-                </a:solidFill>
-                <a:latin typeface="Aptos" panose="020B0004020202020204" pitchFamily="34" charset="0"/>
-              </a:rPr>
-              <a:t>Supervisionados: regressão e classificação no mesmo fluxo</a:t>
-            </a:r>
-          </a:p>
-          <a:p>
-            <a:pPr marL="342900" indent="-342900">
-              <a:spcAft>
-                <a:spcPts val="700"/>
-              </a:spcAft>
-              <a:buFont typeface="+mj-lt"/>
-              <a:buChar char="•"/>
-            </a:pPr>
-            <a:r>
-              <a:rPr lang="pt-BR">
-                <a:solidFill>
-                  <a:srgbClr val="1E2227"/>
-                </a:solidFill>
-                <a:latin typeface="Aptos" panose="020B0004020202020204" pitchFamily="34" charset="0"/>
-              </a:rPr>
-              <a:t>Não supervisionados: clusters, PCA/t-SNE e perfis médios</a:t>
-            </a:r>
-          </a:p>
-          <a:p>
-            <a:pPr marL="342900" indent="-342900">
-              <a:spcAft>
-                <a:spcPts val="700"/>
-              </a:spcAft>
-              <a:buFont typeface="+mj-lt"/>
-              <a:buChar char="•"/>
-            </a:pPr>
-            <a:r>
-              <a:rPr lang="pt-BR">
-                <a:solidFill>
-                  <a:srgbClr val="1E2227"/>
-                </a:solidFill>
-                <a:latin typeface="Aptos" panose="020B0004020202020204" pitchFamily="34" charset="0"/>
-              </a:rPr>
-              <a:t>Associação e outliers: Apriori e LOF em visão consolidada</a:t>
-            </a:r>
-          </a:p>
-          <a:p>
-            <a:pPr marL="342900" indent="-342900">
-              <a:spcAft>
-                <a:spcPts val="700"/>
-              </a:spcAft>
-              <a:buFont typeface="+mj-lt"/>
-              <a:buChar char="•"/>
-            </a:pPr>
-            <a:r>
-              <a:rPr lang="pt-BR">
-                <a:solidFill>
-                  <a:srgbClr val="1E2227"/>
-                </a:solidFill>
-                <a:latin typeface="Aptos" panose="020B0004020202020204" pitchFamily="34" charset="0"/>
-              </a:rPr>
-              <a:t>Placeholders removidos e conclusão executiva atualizada</a:t>
+              <a:t>Preço é resultado da combinação entre tamanho, qualidade, estrutura e idade do imóvel.</a:t>
             </a:r>
           </a:p>
         </p:txBody>
       </p:sp>
       <p:pic>
         <p:nvPicPr>
-          <p:cNvPr id="7" name="Imagem 6">
-            <a:extLst>
-              <a:ext uri="{FF2B5EF4-FFF2-40B4-BE49-F238E27FC236}">
-                <a16:creationId xmlns:a16="http://schemas.microsoft.com/office/drawing/2014/main" id="{6869CB4F-30D5-58F4-0C2E-AFAEA1613D46}"/>
+          <p:cNvPr id="9" name="Imagem 8">
+            <a:extLst>
+              <a:ext uri="{FF2B5EF4-FFF2-40B4-BE49-F238E27FC236}">
+                <a16:creationId xmlns:a16="http://schemas.microsoft.com/office/drawing/2014/main" id="{73FE442C-DEA0-BA2F-A65B-79EEEF656209}"/>
               </a:ext>
             </a:extLst>
           </p:cNvPr>
@@ -5939,44 +5905,8 @@
         </p:blipFill>
         <p:spPr>
           <a:xfrm>
-            <a:off x="7079588" y="1795675"/>
-            <a:ext cx="2223824" cy="637751"/>
-          </a:xfrm>
-          <a:prstGeom prst="rect">
-            <a:avLst/>
-          </a:prstGeom>
-        </p:spPr>
-      </p:pic>
-      <p:pic>
-        <p:nvPicPr>
-          <p:cNvPr id="9" name="Imagem 8">
-            <a:extLst>
-              <a:ext uri="{FF2B5EF4-FFF2-40B4-BE49-F238E27FC236}">
-                <a16:creationId xmlns:a16="http://schemas.microsoft.com/office/drawing/2014/main" id="{F8C2AB76-27B6-65E4-5B12-0445C9C3F811}"/>
-              </a:ext>
-            </a:extLst>
-          </p:cNvPr>
-          <p:cNvPicPr>
-            <a:picLocks noChangeAspect="1"/>
-          </p:cNvPicPr>
-          <p:nvPr/>
-        </p:nvPicPr>
-        <p:blipFill>
-          <a:blip r:embed="rId4">
-            <a:extLst>
-              <a:ext uri="{28A0092B-C50C-407E-A947-70E740481C1C}">
-                <a14:useLocalDpi xmlns:a14="http://schemas.microsoft.com/office/drawing/2010/main" val="0"/>
-              </a:ext>
-            </a:extLst>
-          </a:blip>
-          <a:stretch>
-            <a:fillRect/>
-          </a:stretch>
-        </p:blipFill>
-        <p:spPr>
-          <a:xfrm>
-            <a:off x="7670512" y="4423363"/>
-            <a:ext cx="1041976" cy="602074"/>
+            <a:off x="913476" y="1473110"/>
+            <a:ext cx="10765069" cy="5323522"/>
           </a:xfrm>
           <a:prstGeom prst="rect">
             <a:avLst/>
@@ -5986,7 +5916,7 @@
     </p:spTree>
     <p:extLst>
       <p:ext uri="{BB962C8B-B14F-4D97-AF65-F5344CB8AC3E}">
-        <p14:creationId xmlns:p14="http://schemas.microsoft.com/office/powerpoint/2010/main" val="2049991879"/>
+        <p14:creationId xmlns:p14="http://schemas.microsoft.com/office/powerpoint/2010/main" val="1732430115"/>
       </p:ext>
     </p:extLst>
   </p:cSld>
@@ -6009,7 +5939,13 @@
     </p:bg>
     <p:spTree>
       <p:nvGrpSpPr>
-        <p:cNvPr id="1" name=""/>
+        <p:cNvPr id="1" name="">
+          <a:extLst>
+            <a:ext uri="{FF2B5EF4-FFF2-40B4-BE49-F238E27FC236}">
+              <a16:creationId xmlns:a16="http://schemas.microsoft.com/office/drawing/2014/main" id="{3223A6D0-A5DE-33B0-92F1-F784F63A25AA}"/>
+            </a:ext>
+          </a:extLst>
+        </p:cNvPr>
         <p:cNvGrpSpPr/>
         <p:nvPr/>
       </p:nvGrpSpPr>
@@ -6026,7 +5962,7 @@
           <p:cNvPr id="2" name="Retângulo 1">
             <a:extLst>
               <a:ext uri="{FF2B5EF4-FFF2-40B4-BE49-F238E27FC236}">
-                <a16:creationId xmlns:a16="http://schemas.microsoft.com/office/drawing/2014/main" id="{B6D25A27-2BDF-148A-8D85-5C41DECE5B79}"/>
+                <a16:creationId xmlns:a16="http://schemas.microsoft.com/office/drawing/2014/main" id="{4FB9926A-E5FC-2C01-6EA1-FD885EB0D94C}"/>
               </a:ext>
             </a:extLst>
           </p:cNvPr>
@@ -6094,7 +6030,7 @@
           <p:cNvPr id="3" name="CaixaDeTexto 2">
             <a:extLst>
               <a:ext uri="{FF2B5EF4-FFF2-40B4-BE49-F238E27FC236}">
-                <a16:creationId xmlns:a16="http://schemas.microsoft.com/office/drawing/2014/main" id="{0C96A9D2-C4C1-758C-105B-F92F8FB0A442}"/>
+                <a16:creationId xmlns:a16="http://schemas.microsoft.com/office/drawing/2014/main" id="{93B2D268-8170-A576-241E-748E084CB8F4}"/>
               </a:ext>
             </a:extLst>
           </p:cNvPr>
@@ -6118,13 +6054,13 @@
           <a:lstStyle/>
           <a:p>
             <a:r>
-              <a:rPr lang="pt-BR" sz="2400" b="1">
+              <a:rPr lang="pt-BR" sz="2400" b="1" dirty="0">
                 <a:solidFill>
                   <a:srgbClr val="FFFFFF"/>
                 </a:solidFill>
                 <a:latin typeface="Aptos" panose="020B0004020202020204" pitchFamily="34" charset="0"/>
               </a:rPr>
-              <a:t>Visualização e Storytelling</a:t>
+              <a:t>Resultados Consolidados</a:t>
             </a:r>
           </a:p>
         </p:txBody>
@@ -6134,7 +6070,7 @@
           <p:cNvPr id="4" name="CaixaDeTexto 3">
             <a:extLst>
               <a:ext uri="{FF2B5EF4-FFF2-40B4-BE49-F238E27FC236}">
-                <a16:creationId xmlns:a16="http://schemas.microsoft.com/office/drawing/2014/main" id="{96ADCF12-1C7F-9EB1-38B7-500B90DE0DE0}"/>
+                <a16:creationId xmlns:a16="http://schemas.microsoft.com/office/drawing/2014/main" id="{4E3B655B-5CA2-F6F8-FEED-2AC6E2589C01}"/>
               </a:ext>
             </a:extLst>
           </p:cNvPr>
@@ -6170,131 +6106,12 @@
           </a:p>
         </p:txBody>
       </p:sp>
-      <p:sp>
-        <p:nvSpPr>
-          <p:cNvPr id="5" name="CaixaDeTexto 4">
-            <a:extLst>
-              <a:ext uri="{FF2B5EF4-FFF2-40B4-BE49-F238E27FC236}">
-                <a16:creationId xmlns:a16="http://schemas.microsoft.com/office/drawing/2014/main" id="{65A3445B-AF67-C2CC-1FAC-6FDBAED97B45}"/>
-              </a:ext>
-            </a:extLst>
-          </p:cNvPr>
-          <p:cNvSpPr txBox="1"/>
-          <p:nvPr/>
-        </p:nvSpPr>
-        <p:spPr>
-          <a:xfrm>
-            <a:off x="736600" y="1206500"/>
-            <a:ext cx="4699000" cy="3334246"/>
-          </a:xfrm>
-          <a:prstGeom prst="rect">
-            <a:avLst/>
-          </a:prstGeom>
-          <a:noFill/>
-        </p:spPr>
-        <p:txBody>
-          <a:bodyPr vert="horz" lIns="50800" tIns="25400" rIns="50800" bIns="25400" rtlCol="0">
-            <a:spAutoFit/>
-          </a:bodyPr>
-          <a:lstStyle/>
-          <a:p>
-            <a:pPr marL="457200" indent="-457200">
-              <a:spcAft>
-                <a:spcPts val="700"/>
-              </a:spcAft>
-              <a:buFont typeface="+mj-lt"/>
-              <a:buChar char="•"/>
-            </a:pPr>
-            <a:r>
-              <a:rPr lang="pt-BR" sz="1900">
-                <a:solidFill>
-                  <a:srgbClr val="1E2227"/>
-                </a:solidFill>
-                <a:latin typeface="Aptos" panose="020B0004020202020204" pitchFamily="34" charset="0"/>
-              </a:rPr>
-              <a:t>Distribuições mostram assimetria à direita em SalePrice</a:t>
-            </a:r>
-          </a:p>
-          <a:p>
-            <a:pPr marL="457200" indent="-457200">
-              <a:spcAft>
-                <a:spcPts val="700"/>
-              </a:spcAft>
-              <a:buFont typeface="+mj-lt"/>
-              <a:buChar char="•"/>
-            </a:pPr>
-            <a:r>
-              <a:rPr lang="pt-BR" sz="1900">
-                <a:solidFill>
-                  <a:srgbClr val="1E2227"/>
-                </a:solidFill>
-                <a:latin typeface="Aptos" panose="020B0004020202020204" pitchFamily="34" charset="0"/>
-              </a:rPr>
-              <a:t>Heatmap confirma variáveis ligadas ao preço</a:t>
-            </a:r>
-          </a:p>
-          <a:p>
-            <a:pPr marL="457200" indent="-457200">
-              <a:spcAft>
-                <a:spcPts val="700"/>
-              </a:spcAft>
-              <a:buFont typeface="+mj-lt"/>
-              <a:buChar char="•"/>
-            </a:pPr>
-            <a:r>
-              <a:rPr lang="pt-BR" sz="1900">
-                <a:solidFill>
-                  <a:srgbClr val="1E2227"/>
-                </a:solidFill>
-                <a:latin typeface="Aptos" panose="020B0004020202020204" pitchFamily="34" charset="0"/>
-              </a:rPr>
-              <a:t>Scatter e boxplot reforçam impacto de área e qualidade</a:t>
-            </a:r>
-          </a:p>
-          <a:p>
-            <a:pPr marL="457200" indent="-457200">
-              <a:spcAft>
-                <a:spcPts val="700"/>
-              </a:spcAft>
-              <a:buFont typeface="+mj-lt"/>
-              <a:buChar char="•"/>
-            </a:pPr>
-            <a:r>
-              <a:rPr lang="pt-BR" sz="1900">
-                <a:solidFill>
-                  <a:srgbClr val="1E2227"/>
-                </a:solidFill>
-                <a:latin typeface="Aptos" panose="020B0004020202020204" pitchFamily="34" charset="0"/>
-              </a:rPr>
-              <a:t>Parte 5 conecta modelos supervisionados, clusters, Apriori e LOF</a:t>
-            </a:r>
-          </a:p>
-          <a:p>
-            <a:pPr marL="457200" indent="-457200">
-              <a:spcAft>
-                <a:spcPts val="700"/>
-              </a:spcAft>
-              <a:buFont typeface="+mj-lt"/>
-              <a:buChar char="•"/>
-            </a:pPr>
-            <a:r>
-              <a:rPr lang="pt-BR" sz="1900">
-                <a:solidFill>
-                  <a:srgbClr val="1E2227"/>
-                </a:solidFill>
-                <a:latin typeface="Aptos" panose="020B0004020202020204" pitchFamily="34" charset="0"/>
-              </a:rPr>
-              <a:t>Conclusão final sintetiza o raciocínio analítico do projeto</a:t>
-            </a:r>
-          </a:p>
-        </p:txBody>
-      </p:sp>
       <p:pic>
         <p:nvPicPr>
           <p:cNvPr id="7" name="Imagem 6">
             <a:extLst>
               <a:ext uri="{FF2B5EF4-FFF2-40B4-BE49-F238E27FC236}">
-                <a16:creationId xmlns:a16="http://schemas.microsoft.com/office/drawing/2014/main" id="{247BC0D9-9BA1-A992-5F83-82E2CAB5F232}"/>
+                <a16:creationId xmlns:a16="http://schemas.microsoft.com/office/drawing/2014/main" id="{6FD84B28-4535-59C0-D8AD-07CCDCD72202}"/>
               </a:ext>
             </a:extLst>
           </p:cNvPr>
@@ -6317,59 +6134,18 @@
         </p:blipFill>
         <p:spPr>
           <a:xfrm>
-            <a:off x="7815987" y="1797990"/>
-            <a:ext cx="1132026" cy="849019"/>
+            <a:off x="683053" y="1761294"/>
+            <a:ext cx="10950972" cy="4031952"/>
           </a:xfrm>
           <a:prstGeom prst="rect">
             <a:avLst/>
           </a:prstGeom>
         </p:spPr>
       </p:pic>
-      <p:sp>
-        <p:nvSpPr>
-          <p:cNvPr id="8" name="CaixaDeTexto 7">
-            <a:extLst>
-              <a:ext uri="{FF2B5EF4-FFF2-40B4-BE49-F238E27FC236}">
-                <a16:creationId xmlns:a16="http://schemas.microsoft.com/office/drawing/2014/main" id="{39C760CB-6477-A97E-844E-FC4EA9A83AFF}"/>
-              </a:ext>
-            </a:extLst>
-          </p:cNvPr>
-          <p:cNvSpPr txBox="1"/>
-          <p:nvPr/>
-        </p:nvSpPr>
-        <p:spPr>
-          <a:xfrm>
-            <a:off x="1079500" y="4953000"/>
-            <a:ext cx="9779000" cy="789960"/>
-          </a:xfrm>
-          <a:prstGeom prst="rect">
-            <a:avLst/>
-          </a:prstGeom>
-          <a:noFill/>
-        </p:spPr>
-        <p:txBody>
-          <a:bodyPr vert="horz" lIns="50800" tIns="25400" rIns="50800" bIns="25400" rtlCol="0">
-            <a:spAutoFit/>
-          </a:bodyPr>
-          <a:lstStyle/>
-          <a:p>
-            <a:pPr algn="ctr"/>
-            <a:r>
-              <a:rPr lang="pt-BR" sz="2400" b="1">
-                <a:solidFill>
-                  <a:srgbClr val="162B3A"/>
-                </a:solidFill>
-                <a:latin typeface="Aptos" panose="020B0004020202020204" pitchFamily="34" charset="0"/>
-              </a:rPr>
-              <a:t>Mensagem central: preço é resultado da combinação entre tamanho, qualidade, estrutura e idade do imóvel.</a:t>
-            </a:r>
-          </a:p>
-        </p:txBody>
-      </p:sp>
     </p:spTree>
     <p:extLst>
       <p:ext uri="{BB962C8B-B14F-4D97-AF65-F5344CB8AC3E}">
-        <p14:creationId xmlns:p14="http://schemas.microsoft.com/office/powerpoint/2010/main" val="1732430115"/>
+        <p14:creationId xmlns:p14="http://schemas.microsoft.com/office/powerpoint/2010/main" val="3696430209"/>
       </p:ext>
     </p:extLst>
   </p:cSld>
@@ -6542,13 +6318,13 @@
           <a:p>
             <a:pPr algn="r"/>
             <a:r>
-              <a:rPr lang="pt-BR" sz="1200">
+              <a:rPr lang="pt-BR" sz="1200" dirty="0">
                 <a:solidFill>
                   <a:srgbClr val="FFFFFF"/>
                 </a:solidFill>
                 <a:latin typeface="Aptos" panose="020B0004020202020204" pitchFamily="34" charset="0"/>
               </a:rPr>
-              <a:t>fechamento</a:t>
+              <a:t>Fechamento</a:t>
             </a:r>
           </a:p>
         </p:txBody>
@@ -6567,7 +6343,7 @@
         </p:nvSpPr>
         <p:spPr>
           <a:xfrm>
-            <a:off x="825500" y="1206500"/>
+            <a:off x="825500" y="1151268"/>
             <a:ext cx="2413000" cy="1117600"/>
           </a:xfrm>
           <a:prstGeom prst="rect">
@@ -6637,7 +6413,7 @@
           <a:p>
             <a:pPr algn="ctr"/>
             <a:r>
-              <a:rPr lang="pt-BR" sz="2500" b="1">
+              <a:rPr lang="pt-BR" sz="2500" b="1" dirty="0">
                 <a:solidFill>
                   <a:srgbClr val="268984"/>
                 </a:solidFill>
@@ -6703,7 +6479,7 @@
         </p:nvSpPr>
         <p:spPr>
           <a:xfrm>
-            <a:off x="3619500" y="1206500"/>
+            <a:off x="3619500" y="1151268"/>
             <a:ext cx="2159000" cy="1117600"/>
           </a:xfrm>
           <a:prstGeom prst="rect">
@@ -6839,7 +6615,7 @@
         </p:nvSpPr>
         <p:spPr>
           <a:xfrm>
-            <a:off x="6159500" y="1206500"/>
+            <a:off x="6159500" y="1151268"/>
             <a:ext cx="2413000" cy="1117600"/>
           </a:xfrm>
           <a:prstGeom prst="rect">
@@ -6975,7 +6751,7 @@
         </p:nvSpPr>
         <p:spPr>
           <a:xfrm>
-            <a:off x="8953500" y="1206500"/>
+            <a:off x="8953500" y="1151268"/>
             <a:ext cx="1905000" cy="1117600"/>
           </a:xfrm>
           <a:prstGeom prst="rect">
@@ -7112,7 +6888,7 @@
         <p:spPr>
           <a:xfrm>
             <a:off x="1333500" y="3175000"/>
-            <a:ext cx="9525000" cy="1949252"/>
+            <a:ext cx="9525000" cy="2205732"/>
           </a:xfrm>
           <a:prstGeom prst="rect">
             <a:avLst/>
@@ -7125,93 +6901,64 @@
           </a:bodyPr>
           <a:lstStyle/>
           <a:p>
-            <a:pPr marL="457200" indent="-457200">
-              <a:spcAft>
-                <a:spcPts val="700"/>
-              </a:spcAft>
-              <a:buFont typeface="+mj-lt"/>
+            <a:endParaRPr lang="pt-BR" sz="2000" dirty="0"/>
+          </a:p>
+          <a:p>
+            <a:pPr marL="285750" indent="-285750">
+              <a:buFont typeface="Arial" panose="020B0604020202020204" pitchFamily="34" charset="0"/>
               <a:buChar char="•"/>
             </a:pPr>
             <a:r>
-              <a:rPr lang="pt-BR" sz="2000">
-                <a:solidFill>
-                  <a:srgbClr val="1E2227"/>
-                </a:solidFill>
-                <a:latin typeface="Aptos" panose="020B0004020202020204" pitchFamily="34" charset="0"/>
-              </a:rPr>
-              <a:t>Todos os critérios técnicos foram contemplados</a:t>
-            </a:r>
-          </a:p>
-          <a:p>
-            <a:pPr marL="457200" indent="-457200">
-              <a:spcAft>
-                <a:spcPts val="700"/>
-              </a:spcAft>
-              <a:buFont typeface="+mj-lt"/>
+              <a:rPr lang="pt-BR" sz="2000" dirty="0"/>
+              <a:t>O preço não depende de uma única variável</a:t>
+            </a:r>
+          </a:p>
+          <a:p>
+            <a:pPr marL="285750" indent="-285750">
+              <a:buFont typeface="Arial" panose="020B0604020202020204" pitchFamily="34" charset="0"/>
               <a:buChar char="•"/>
             </a:pPr>
             <a:r>
-              <a:rPr lang="pt-BR" sz="2000">
-                <a:solidFill>
-                  <a:srgbClr val="1E2227"/>
-                </a:solidFill>
-                <a:latin typeface="Aptos" panose="020B0004020202020204" pitchFamily="34" charset="0"/>
-              </a:rPr>
-              <a:t>Notebook 06 agora inclui gráficos consolidados dos modelos</a:t>
-            </a:r>
-          </a:p>
-          <a:p>
-            <a:pPr marL="457200" indent="-457200">
-              <a:spcAft>
-                <a:spcPts val="700"/>
-              </a:spcAft>
-              <a:buFont typeface="+mj-lt"/>
+              <a:rPr lang="pt-BR" sz="2000" dirty="0"/>
+              <a:t>Qualidade geral, área total, área habitável, banheiros, garagem e idade são sinais centrais</a:t>
+            </a:r>
+          </a:p>
+          <a:p>
+            <a:pPr marL="285750" indent="-285750">
+              <a:buFont typeface="Arial" panose="020B0604020202020204" pitchFamily="34" charset="0"/>
               <a:buChar char="•"/>
             </a:pPr>
             <a:r>
-              <a:rPr lang="pt-BR" sz="2000">
-                <a:solidFill>
-                  <a:srgbClr val="1E2227"/>
-                </a:solidFill>
-                <a:latin typeface="Aptos" panose="020B0004020202020204" pitchFamily="34" charset="0"/>
-              </a:rPr>
-              <a:t>Storytelling foi atualizado sem placeholders</a:t>
-            </a:r>
-          </a:p>
-          <a:p>
-            <a:pPr marL="457200" indent="-457200">
-              <a:spcAft>
-                <a:spcPts val="700"/>
-              </a:spcAft>
-              <a:buFont typeface="+mj-lt"/>
+              <a:rPr lang="pt-BR" sz="2000" dirty="0"/>
+              <a:t>Feature </a:t>
+            </a:r>
+            <a:r>
+              <a:rPr lang="pt-BR" sz="2000" dirty="0" err="1"/>
+              <a:t>engineering</a:t>
+            </a:r>
+            <a:r>
+              <a:rPr lang="pt-BR" sz="2000" dirty="0"/>
+              <a:t> melhorou a interpretação e alimentou melhor os modelos</a:t>
+            </a:r>
+          </a:p>
+          <a:p>
+            <a:pPr marL="285750" indent="-285750">
+              <a:buFont typeface="Arial" panose="020B0604020202020204" pitchFamily="34" charset="0"/>
               <a:buChar char="•"/>
             </a:pPr>
             <a:r>
-              <a:rPr lang="pt-BR" sz="2000">
-                <a:solidFill>
-                  <a:srgbClr val="1E2227"/>
-                </a:solidFill>
-                <a:latin typeface="Aptos" panose="020B0004020202020204" pitchFamily="34" charset="0"/>
-              </a:rPr>
-              <a:t>Feature engineering aparece nos modelos e na interpretação</a:t>
-            </a:r>
-          </a:p>
-          <a:p>
-            <a:pPr marL="457200" indent="-457200">
-              <a:spcAft>
-                <a:spcPts val="700"/>
-              </a:spcAft>
-              <a:buFont typeface="+mj-lt"/>
+              <a:rPr lang="pt-BR" sz="2000" dirty="0"/>
+              <a:t>Modelos supervisionados tiveram forte poder preditivo</a:t>
+            </a:r>
+          </a:p>
+          <a:p>
+            <a:pPr marL="285750" indent="-285750">
+              <a:buFont typeface="Arial" panose="020B0604020202020204" pitchFamily="34" charset="0"/>
               <a:buChar char="•"/>
             </a:pPr>
             <a:r>
-              <a:rPr lang="pt-BR" sz="2000">
-                <a:solidFill>
-                  <a:srgbClr val="1E2227"/>
-                </a:solidFill>
-                <a:latin typeface="Aptos" panose="020B0004020202020204" pitchFamily="34" charset="0"/>
-              </a:rPr>
-              <a:t>O preço é explicado por tamanho, qualidade, estrutura, idade e conservação</a:t>
+              <a:rPr lang="pt-BR" sz="2000" dirty="0"/>
+              <a:t>Modelos não supervisionados revelaram perfis e anomalias úteis</a:t>
             </a:r>
           </a:p>
         </p:txBody>
@@ -7392,13 +7139,13 @@
           <a:p>
             <a:pPr algn="r"/>
             <a:r>
-              <a:rPr lang="pt-BR" sz="1200">
+              <a:rPr lang="pt-BR" sz="1200" dirty="0">
                 <a:solidFill>
                   <a:srgbClr val="FFFFFF"/>
                 </a:solidFill>
                 <a:latin typeface="Aptos" panose="020B0004020202020204" pitchFamily="34" charset="0"/>
               </a:rPr>
-              <a:t>obrigado</a:t>
+              <a:t>Fim</a:t>
             </a:r>
           </a:p>
         </p:txBody>
@@ -7417,7 +7164,7 @@
         </p:nvSpPr>
         <p:spPr>
           <a:xfrm>
-            <a:off x="1016000" y="1841500"/>
+            <a:off x="923946" y="3259127"/>
             <a:ext cx="10160000" cy="728405"/>
           </a:xfrm>
           <a:prstGeom prst="rect">
@@ -7433,149 +7180,13 @@
           <a:p>
             <a:pPr algn="ctr"/>
             <a:r>
-              <a:rPr lang="pt-BR" sz="4400" b="1">
+              <a:rPr lang="pt-BR" sz="4400" b="1" dirty="0">
                 <a:solidFill>
                   <a:srgbClr val="162B3A"/>
                 </a:solidFill>
                 <a:latin typeface="Aptos" panose="020B0004020202020204" pitchFamily="34" charset="0"/>
               </a:rPr>
               <a:t>Obrigado!</a:t>
-            </a:r>
-          </a:p>
-        </p:txBody>
-      </p:sp>
-      <p:sp>
-        <p:nvSpPr>
-          <p:cNvPr id="6" name="CaixaDeTexto 5">
-            <a:extLst>
-              <a:ext uri="{FF2B5EF4-FFF2-40B4-BE49-F238E27FC236}">
-                <a16:creationId xmlns:a16="http://schemas.microsoft.com/office/drawing/2014/main" id="{1B249FE1-7FED-FEBC-6038-574EC5ED85D2}"/>
-              </a:ext>
-            </a:extLst>
-          </p:cNvPr>
-          <p:cNvSpPr txBox="1"/>
-          <p:nvPr/>
-        </p:nvSpPr>
-        <p:spPr>
-          <a:xfrm>
-            <a:off x="1651000" y="3048000"/>
-            <a:ext cx="8890000" cy="482183"/>
-          </a:xfrm>
-          <a:prstGeom prst="rect">
-            <a:avLst/>
-          </a:prstGeom>
-          <a:noFill/>
-        </p:spPr>
-        <p:txBody>
-          <a:bodyPr vert="horz" lIns="50800" tIns="25400" rIns="50800" bIns="25400" rtlCol="0">
-            <a:spAutoFit/>
-          </a:bodyPr>
-          <a:lstStyle/>
-          <a:p>
-            <a:pPr algn="ctr"/>
-            <a:r>
-              <a:rPr lang="pt-BR" sz="2800">
-                <a:solidFill>
-                  <a:srgbClr val="585F69"/>
-                </a:solidFill>
-                <a:latin typeface="Aptos" panose="020B0004020202020204" pitchFamily="34" charset="0"/>
-              </a:rPr>
-              <a:t>Estamos à disposição para perguntas.</a:t>
-            </a:r>
-          </a:p>
-        </p:txBody>
-      </p:sp>
-      <p:sp>
-        <p:nvSpPr>
-          <p:cNvPr id="7" name="Retângulo 6">
-            <a:extLst>
-              <a:ext uri="{FF2B5EF4-FFF2-40B4-BE49-F238E27FC236}">
-                <a16:creationId xmlns:a16="http://schemas.microsoft.com/office/drawing/2014/main" id="{663A1A4B-89A2-14BC-731F-5E38F6442C40}"/>
-              </a:ext>
-            </a:extLst>
-          </p:cNvPr>
-          <p:cNvSpPr/>
-          <p:nvPr/>
-        </p:nvSpPr>
-        <p:spPr>
-          <a:xfrm>
-            <a:off x="2794000" y="4381500"/>
-            <a:ext cx="6604000" cy="736600"/>
-          </a:xfrm>
-          <a:prstGeom prst="rect">
-            <a:avLst/>
-          </a:prstGeom>
-          <a:solidFill>
-            <a:srgbClr val="F6F8FA"/>
-          </a:solidFill>
-          <a:ln>
-            <a:solidFill>
-              <a:srgbClr val="DCE0E4"/>
-            </a:solidFill>
-          </a:ln>
-        </p:spPr>
-        <p:style>
-          <a:lnRef idx="2">
-            <a:schemeClr val="accent1">
-              <a:shade val="15000"/>
-            </a:schemeClr>
-          </a:lnRef>
-          <a:fillRef idx="1">
-            <a:schemeClr val="accent1"/>
-          </a:fillRef>
-          <a:effectRef idx="0">
-            <a:schemeClr val="accent1"/>
-          </a:effectRef>
-          <a:fontRef idx="minor">
-            <a:schemeClr val="lt1"/>
-          </a:fontRef>
-        </p:style>
-        <p:txBody>
-          <a:bodyPr rtlCol="0" anchor="ctr"/>
-          <a:lstStyle/>
-          <a:p>
-            <a:pPr algn="ctr"/>
-            <a:endParaRPr lang="pt-BR"/>
-          </a:p>
-        </p:txBody>
-      </p:sp>
-      <p:sp>
-        <p:nvSpPr>
-          <p:cNvPr id="8" name="CaixaDeTexto 7">
-            <a:extLst>
-              <a:ext uri="{FF2B5EF4-FFF2-40B4-BE49-F238E27FC236}">
-                <a16:creationId xmlns:a16="http://schemas.microsoft.com/office/drawing/2014/main" id="{CDF51E2E-7B61-D88D-10E3-EDDA3A16A633}"/>
-              </a:ext>
-            </a:extLst>
-          </p:cNvPr>
-          <p:cNvSpPr txBox="1"/>
-          <p:nvPr/>
-        </p:nvSpPr>
-        <p:spPr>
-          <a:xfrm>
-            <a:off x="3111500" y="4521200"/>
-            <a:ext cx="5969000" cy="482183"/>
-          </a:xfrm>
-          <a:prstGeom prst="rect">
-            <a:avLst/>
-          </a:prstGeom>
-          <a:noFill/>
-        </p:spPr>
-        <p:txBody>
-          <a:bodyPr vert="horz" lIns="50800" tIns="25400" rIns="50800" bIns="25400" rtlCol="0">
-            <a:spAutoFit/>
-          </a:bodyPr>
-          <a:lstStyle/>
-          <a:p>
-            <a:pPr algn="ctr"/>
-            <a:r>
-              <a:rPr lang="pt-BR" sz="1400">
-                <a:solidFill>
-                  <a:srgbClr val="1E2227"/>
-                </a:solidFill>
-                <a:latin typeface="Aptos" panose="020B0004020202020204" pitchFamily="34" charset="0"/>
-              </a:rPr>
-              <a:t>Resposta rápida: Silhouette baixo é esperado em dados imobiliários com sobreposição, mas os clusters ainda têm perfis médios interpretáveis.</a:t>
             </a:r>
           </a:p>
         </p:txBody>
@@ -8874,7 +8485,7 @@
         <p:spPr>
           <a:xfrm>
             <a:off x="850900" y="2794000"/>
-            <a:ext cx="1346200" cy="543739"/>
+            <a:ext cx="1346200" cy="266740"/>
           </a:xfrm>
           <a:prstGeom prst="rect">
             <a:avLst/>
@@ -8889,7 +8500,7 @@
           <a:p>
             <a:pPr algn="ctr"/>
             <a:r>
-              <a:rPr lang="pt-BR" sz="1600" b="1">
+              <a:rPr lang="pt-BR" sz="1400" b="1" dirty="0">
                 <a:solidFill>
                   <a:srgbClr val="162B3A"/>
                 </a:solidFill>
@@ -9010,7 +8621,7 @@
         <p:spPr>
           <a:xfrm>
             <a:off x="2730500" y="2794000"/>
-            <a:ext cx="1346200" cy="543739"/>
+            <a:ext cx="1346200" cy="482183"/>
           </a:xfrm>
           <a:prstGeom prst="rect">
             <a:avLst/>
@@ -9025,14 +8636,29 @@
           <a:p>
             <a:pPr algn="ctr"/>
             <a:r>
-              <a:rPr lang="pt-BR" sz="1600" b="1">
+              <a:rPr lang="pt-BR" sz="1400" b="1" dirty="0">
                 <a:solidFill>
                   <a:srgbClr val="162B3A"/>
                 </a:solidFill>
                 <a:latin typeface="Aptos" panose="020B0004020202020204" pitchFamily="34" charset="0"/>
               </a:rPr>
-              <a:t>Feature engineering</a:t>
-            </a:r>
+              <a:t>Feature </a:t>
+            </a:r>
+            <a:r>
+              <a:rPr lang="pt-BR" sz="1400" b="1" dirty="0" err="1">
+                <a:solidFill>
+                  <a:srgbClr val="162B3A"/>
+                </a:solidFill>
+                <a:latin typeface="Aptos" panose="020B0004020202020204" pitchFamily="34" charset="0"/>
+              </a:rPr>
+              <a:t>engineering</a:t>
+            </a:r>
+            <a:endParaRPr lang="pt-BR" sz="1400" b="1" dirty="0">
+              <a:solidFill>
+                <a:srgbClr val="162B3A"/>
+              </a:solidFill>
+              <a:latin typeface="Aptos" panose="020B0004020202020204" pitchFamily="34" charset="0"/>
+            </a:endParaRPr>
           </a:p>
         </p:txBody>
       </p:sp>
@@ -9146,7 +8772,7 @@
         <p:spPr>
           <a:xfrm>
             <a:off x="4610100" y="2794000"/>
-            <a:ext cx="1346200" cy="297517"/>
+            <a:ext cx="1346200" cy="266740"/>
           </a:xfrm>
           <a:prstGeom prst="rect">
             <a:avLst/>
@@ -9161,7 +8787,7 @@
           <a:p>
             <a:pPr algn="ctr"/>
             <a:r>
-              <a:rPr lang="pt-BR" sz="1600" b="1">
+              <a:rPr lang="pt-BR" sz="1400" b="1" dirty="0">
                 <a:solidFill>
                   <a:srgbClr val="162B3A"/>
                 </a:solidFill>
@@ -9169,6 +8795,12 @@
               </a:rPr>
               <a:t>Regressão</a:t>
             </a:r>
+            <a:endParaRPr lang="pt-BR" sz="1600" b="1" dirty="0">
+              <a:solidFill>
+                <a:srgbClr val="162B3A"/>
+              </a:solidFill>
+              <a:latin typeface="Aptos" panose="020B0004020202020204" pitchFamily="34" charset="0"/>
+            </a:endParaRPr>
           </a:p>
         </p:txBody>
       </p:sp>
@@ -9282,7 +8914,7 @@
         <p:spPr>
           <a:xfrm>
             <a:off x="6489700" y="2794000"/>
-            <a:ext cx="1346200" cy="543739"/>
+            <a:ext cx="1346200" cy="266740"/>
           </a:xfrm>
           <a:prstGeom prst="rect">
             <a:avLst/>
@@ -9297,7 +8929,7 @@
           <a:p>
             <a:pPr algn="ctr"/>
             <a:r>
-              <a:rPr lang="pt-BR" sz="1600" b="1">
+              <a:rPr lang="pt-BR" sz="1400" b="1" dirty="0">
                 <a:solidFill>
                   <a:srgbClr val="162B3A"/>
                 </a:solidFill>
@@ -9418,7 +9050,7 @@
         <p:spPr>
           <a:xfrm>
             <a:off x="8369300" y="2794000"/>
-            <a:ext cx="1346200" cy="543739"/>
+            <a:ext cx="1346200" cy="266740"/>
           </a:xfrm>
           <a:prstGeom prst="rect">
             <a:avLst/>
@@ -9433,7 +9065,7 @@
           <a:p>
             <a:pPr algn="ctr"/>
             <a:r>
-              <a:rPr lang="pt-BR" sz="1600" b="1">
+              <a:rPr lang="pt-BR" sz="1400" b="1" dirty="0">
                 <a:solidFill>
                   <a:srgbClr val="162B3A"/>
                 </a:solidFill>
@@ -9554,7 +9186,7 @@
         <p:spPr>
           <a:xfrm>
             <a:off x="10248900" y="2794000"/>
-            <a:ext cx="1346200" cy="789960"/>
+            <a:ext cx="1346200" cy="697627"/>
           </a:xfrm>
           <a:prstGeom prst="rect">
             <a:avLst/>
@@ -9569,14 +9201,29 @@
           <a:p>
             <a:pPr algn="ctr"/>
             <a:r>
-              <a:rPr lang="pt-BR" sz="1600" b="1">
+              <a:rPr lang="pt-BR" sz="1400" b="1" dirty="0">
                 <a:solidFill>
                   <a:srgbClr val="162B3A"/>
                 </a:solidFill>
                 <a:latin typeface="Aptos" panose="020B0004020202020204" pitchFamily="34" charset="0"/>
               </a:rPr>
-              <a:t>Associação, outliers e storytelling</a:t>
-            </a:r>
+              <a:t>Associação, outliers e </a:t>
+            </a:r>
+            <a:r>
+              <a:rPr lang="pt-BR" sz="1400" b="1" dirty="0" err="1">
+                <a:solidFill>
+                  <a:srgbClr val="162B3A"/>
+                </a:solidFill>
+                <a:latin typeface="Aptos" panose="020B0004020202020204" pitchFamily="34" charset="0"/>
+              </a:rPr>
+              <a:t>storytelling</a:t>
+            </a:r>
+            <a:endParaRPr lang="pt-BR" sz="1400" b="1" dirty="0">
+              <a:solidFill>
+                <a:srgbClr val="162B3A"/>
+              </a:solidFill>
+              <a:latin typeface="Aptos" panose="020B0004020202020204" pitchFamily="34" charset="0"/>
+            </a:endParaRPr>
           </a:p>
         </p:txBody>
       </p:sp>
@@ -9955,8 +9602,8 @@
         </p:blipFill>
         <p:spPr>
           <a:xfrm>
-            <a:off x="7525642" y="1783664"/>
-            <a:ext cx="2411215" cy="1004673"/>
+            <a:off x="5895994" y="1104644"/>
+            <a:ext cx="5940406" cy="2475169"/>
           </a:xfrm>
           <a:prstGeom prst="rect">
             <a:avLst/>
@@ -9991,8 +9638,8 @@
         </p:blipFill>
         <p:spPr>
           <a:xfrm>
-            <a:off x="7881573" y="4464662"/>
-            <a:ext cx="1699354" cy="849677"/>
+            <a:off x="6096000" y="3766733"/>
+            <a:ext cx="5801534" cy="2900767"/>
           </a:xfrm>
           <a:prstGeom prst="rect">
             <a:avLst/>
@@ -10319,8 +9966,8 @@
         </p:nvSpPr>
         <p:spPr>
           <a:xfrm>
-            <a:off x="6858000" y="1460500"/>
-            <a:ext cx="3937000" cy="2857500"/>
+            <a:off x="6794500" y="1460499"/>
+            <a:ext cx="3937000" cy="3467441"/>
           </a:xfrm>
           <a:prstGeom prst="rect">
             <a:avLst/>
@@ -10389,13 +10036,13 @@
           <a:p>
             <a:pPr algn="ctr"/>
             <a:r>
-              <a:rPr lang="pt-BR" sz="2400" b="1">
+              <a:rPr lang="pt-BR" sz="2400" b="1" dirty="0">
                 <a:solidFill>
                   <a:srgbClr val="162B3A"/>
                 </a:solidFill>
                 <a:latin typeface="Aptos" panose="020B0004020202020204" pitchFamily="34" charset="0"/>
               </a:rPr>
-              <a:t>Por que isso importa?</a:t>
+              <a:t>Features criadas</a:t>
             </a:r>
           </a:p>
         </p:txBody>
@@ -10915,7 +10562,7 @@
         <p:spPr>
           <a:xfrm>
             <a:off x="762000" y="2921000"/>
-            <a:ext cx="4572000" cy="1982594"/>
+            <a:ext cx="4165941" cy="2259593"/>
           </a:xfrm>
           <a:prstGeom prst="rect">
             <a:avLst/>
@@ -10923,7 +10570,7 @@
           <a:noFill/>
         </p:spPr>
         <p:txBody>
-          <a:bodyPr vert="horz" lIns="50800" tIns="25400" rIns="50800" bIns="25400" rtlCol="0">
+          <a:bodyPr vert="horz" wrap="square" lIns="50800" tIns="25400" rIns="50800" bIns="25400" rtlCol="0">
             <a:spAutoFit/>
           </a:bodyPr>
           <a:lstStyle/>
@@ -10936,14 +10583,47 @@
               <a:buChar char="•"/>
             </a:pPr>
             <a:r>
-              <a:rPr lang="pt-BR">
+              <a:rPr lang="pt-BR" dirty="0">
                 <a:solidFill>
                   <a:srgbClr val="1E2227"/>
                 </a:solidFill>
                 <a:latin typeface="Aptos" panose="020B0004020202020204" pitchFamily="34" charset="0"/>
               </a:rPr>
-              <a:t>Modelo simples: GrLivArea -&gt; SalePrice</a:t>
-            </a:r>
+              <a:t>Modelo simples: </a:t>
+            </a:r>
+            <a:r>
+              <a:rPr lang="pt-BR" dirty="0" err="1">
+                <a:solidFill>
+                  <a:srgbClr val="1E2227"/>
+                </a:solidFill>
+                <a:latin typeface="Aptos" panose="020B0004020202020204" pitchFamily="34" charset="0"/>
+              </a:rPr>
+              <a:t>GrLivArea</a:t>
+            </a:r>
+            <a:r>
+              <a:rPr lang="pt-BR" dirty="0">
+                <a:solidFill>
+                  <a:srgbClr val="1E2227"/>
+                </a:solidFill>
+                <a:latin typeface="Aptos" panose="020B0004020202020204" pitchFamily="34" charset="0"/>
+              </a:rPr>
+              <a:t> -&gt; </a:t>
+            </a:r>
+            <a:r>
+              <a:rPr lang="pt-BR" dirty="0" err="1">
+                <a:solidFill>
+                  <a:srgbClr val="1E2227"/>
+                </a:solidFill>
+                <a:latin typeface="Aptos" panose="020B0004020202020204" pitchFamily="34" charset="0"/>
+              </a:rPr>
+              <a:t>SalePrice</a:t>
+            </a:r>
+            <a:endParaRPr lang="pt-BR" dirty="0">
+              <a:solidFill>
+                <a:srgbClr val="1E2227"/>
+              </a:solidFill>
+              <a:latin typeface="Aptos" panose="020B0004020202020204" pitchFamily="34" charset="0"/>
+            </a:endParaRPr>
           </a:p>
           <a:p>
             <a:pPr marL="342900" indent="-342900">
@@ -10954,7 +10634,7 @@
               <a:buChar char="•"/>
             </a:pPr>
             <a:r>
-              <a:rPr lang="pt-BR">
+              <a:rPr lang="pt-BR" dirty="0">
                 <a:solidFill>
                   <a:srgbClr val="1E2227"/>
                 </a:solidFill>
@@ -10972,13 +10652,40 @@
               <a:buChar char="•"/>
             </a:pPr>
             <a:r>
-              <a:rPr lang="pt-BR">
+              <a:rPr lang="pt-BR" dirty="0" err="1">
                 <a:solidFill>
                   <a:srgbClr val="1E2227"/>
                 </a:solidFill>
                 <a:latin typeface="Aptos" panose="020B0004020202020204" pitchFamily="34" charset="0"/>
               </a:rPr>
-              <a:t>TotalSF e TotalBathrooms aparecem entre os principais preditores</a:t>
+              <a:t>TotalSF</a:t>
+            </a:r>
+            <a:r>
+              <a:rPr lang="pt-BR" dirty="0">
+                <a:solidFill>
+                  <a:srgbClr val="1E2227"/>
+                </a:solidFill>
+                <a:latin typeface="Aptos" panose="020B0004020202020204" pitchFamily="34" charset="0"/>
+              </a:rPr>
+              <a:t> e </a:t>
+            </a:r>
+            <a:r>
+              <a:rPr lang="pt-BR" dirty="0" err="1">
+                <a:solidFill>
+                  <a:srgbClr val="1E2227"/>
+                </a:solidFill>
+                <a:latin typeface="Aptos" panose="020B0004020202020204" pitchFamily="34" charset="0"/>
+              </a:rPr>
+              <a:t>TotalBathrooms</a:t>
+            </a:r>
+            <a:r>
+              <a:rPr lang="pt-BR" dirty="0">
+                <a:solidFill>
+                  <a:srgbClr val="1E2227"/>
+                </a:solidFill>
+                <a:latin typeface="Aptos" panose="020B0004020202020204" pitchFamily="34" charset="0"/>
+              </a:rPr>
+              <a:t> aparecem entre os principais preditores</a:t>
             </a:r>
           </a:p>
           <a:p>
@@ -10990,7 +10697,7 @@
               <a:buChar char="•"/>
             </a:pPr>
             <a:r>
-              <a:rPr lang="pt-BR">
+              <a:rPr lang="pt-BR" dirty="0">
                 <a:solidFill>
                   <a:srgbClr val="1E2227"/>
                 </a:solidFill>
@@ -11029,8 +10736,8 @@
         </p:blipFill>
         <p:spPr>
           <a:xfrm>
-            <a:off x="7397089" y="1955960"/>
-            <a:ext cx="2223822" cy="736279"/>
+            <a:off x="5588000" y="1044295"/>
+            <a:ext cx="6394925" cy="2259594"/>
           </a:xfrm>
           <a:prstGeom prst="rect">
             <a:avLst/>
@@ -11065,8 +10772,8 @@
         </p:blipFill>
         <p:spPr>
           <a:xfrm>
-            <a:off x="7449056" y="4447334"/>
-            <a:ext cx="2119888" cy="820832"/>
+            <a:off x="4786792" y="3646790"/>
+            <a:ext cx="7329758" cy="3138474"/>
           </a:xfrm>
           <a:prstGeom prst="rect">
             <a:avLst/>
@@ -11661,8 +11368,8 @@
         </p:blipFill>
         <p:spPr>
           <a:xfrm>
-            <a:off x="7669460" y="1854528"/>
-            <a:ext cx="1933080" cy="786744"/>
+            <a:off x="6155085" y="1206500"/>
+            <a:ext cx="5721848" cy="2328734"/>
           </a:xfrm>
           <a:prstGeom prst="rect">
             <a:avLst/>
@@ -11697,8 +11404,8 @@
         </p:blipFill>
         <p:spPr>
           <a:xfrm>
-            <a:off x="7642933" y="4426465"/>
-            <a:ext cx="1986135" cy="862570"/>
+            <a:off x="6139598" y="3976719"/>
+            <a:ext cx="5609896" cy="2436354"/>
           </a:xfrm>
           <a:prstGeom prst="rect">
             <a:avLst/>
@@ -11906,8 +11613,8 @@
         </p:nvSpPr>
         <p:spPr>
           <a:xfrm>
-            <a:off x="635000" y="1168400"/>
-            <a:ext cx="4953000" cy="2626360"/>
+            <a:off x="634999" y="1168400"/>
+            <a:ext cx="5084603" cy="1338828"/>
           </a:xfrm>
           <a:prstGeom prst="rect">
             <a:avLst/>
@@ -11915,7 +11622,7 @@
           <a:noFill/>
         </p:spPr>
         <p:txBody>
-          <a:bodyPr vert="horz" lIns="50800" tIns="25400" rIns="50800" bIns="25400" rtlCol="0">
+          <a:bodyPr vert="horz" wrap="square" lIns="50800" tIns="25400" rIns="50800" bIns="25400" rtlCol="0">
             <a:spAutoFit/>
           </a:bodyPr>
           <a:lstStyle/>
@@ -11928,13 +11635,31 @@
               <a:buChar char="•"/>
             </a:pPr>
             <a:r>
-              <a:rPr lang="pt-BR">
+              <a:rPr lang="pt-BR" dirty="0">
                 <a:solidFill>
                   <a:srgbClr val="1E2227"/>
                 </a:solidFill>
                 <a:latin typeface="Aptos" panose="020B0004020202020204" pitchFamily="34" charset="0"/>
               </a:rPr>
-              <a:t>K-Means para perfis de imóveis sem usar preço no treino</a:t>
+              <a:t>K-</a:t>
+            </a:r>
+            <a:r>
+              <a:rPr lang="pt-BR" dirty="0" err="1">
+                <a:solidFill>
+                  <a:srgbClr val="1E2227"/>
+                </a:solidFill>
+                <a:latin typeface="Aptos" panose="020B0004020202020204" pitchFamily="34" charset="0"/>
+              </a:rPr>
+              <a:t>Means</a:t>
+            </a:r>
+            <a:r>
+              <a:rPr lang="pt-BR" dirty="0">
+                <a:solidFill>
+                  <a:srgbClr val="1E2227"/>
+                </a:solidFill>
+                <a:latin typeface="Aptos" panose="020B0004020202020204" pitchFamily="34" charset="0"/>
+              </a:rPr>
+              <a:t> para perfis de imóveis sem usar preço no treino</a:t>
             </a:r>
           </a:p>
           <a:p>
@@ -11946,13 +11671,40 @@
               <a:buChar char="•"/>
             </a:pPr>
             <a:r>
-              <a:rPr lang="pt-BR">
+              <a:rPr lang="pt-BR" dirty="0" err="1">
                 <a:solidFill>
                   <a:srgbClr val="1E2227"/>
                 </a:solidFill>
                 <a:latin typeface="Aptos" panose="020B0004020202020204" pitchFamily="34" charset="0"/>
               </a:rPr>
-              <a:t>Elbow Method apoiou a escolha de k</a:t>
+              <a:t>Elbow</a:t>
+            </a:r>
+            <a:r>
+              <a:rPr lang="pt-BR" dirty="0">
+                <a:solidFill>
+                  <a:srgbClr val="1E2227"/>
+                </a:solidFill>
+                <a:latin typeface="Aptos" panose="020B0004020202020204" pitchFamily="34" charset="0"/>
+              </a:rPr>
+              <a:t> </a:t>
+            </a:r>
+            <a:r>
+              <a:rPr lang="pt-BR" dirty="0" err="1">
+                <a:solidFill>
+                  <a:srgbClr val="1E2227"/>
+                </a:solidFill>
+                <a:latin typeface="Aptos" panose="020B0004020202020204" pitchFamily="34" charset="0"/>
+              </a:rPr>
+              <a:t>Method</a:t>
+            </a:r>
+            <a:r>
+              <a:rPr lang="pt-BR" dirty="0">
+                <a:solidFill>
+                  <a:srgbClr val="1E2227"/>
+                </a:solidFill>
+                <a:latin typeface="Aptos" panose="020B0004020202020204" pitchFamily="34" charset="0"/>
+              </a:rPr>
+              <a:t> apoiou a escolha de k</a:t>
             </a:r>
           </a:p>
           <a:p>
@@ -11964,7 +11716,7 @@
               <a:buChar char="•"/>
             </a:pPr>
             <a:r>
-              <a:rPr lang="pt-BR">
+              <a:rPr lang="pt-BR" dirty="0">
                 <a:solidFill>
                   <a:srgbClr val="1E2227"/>
                 </a:solidFill>
@@ -11973,6 +11725,71 @@
               <a:t>PCA e t-SNE para visualização em 2D</a:t>
             </a:r>
           </a:p>
+        </p:txBody>
+      </p:sp>
+      <p:pic>
+        <p:nvPicPr>
+          <p:cNvPr id="7" name="Imagem 6">
+            <a:extLst>
+              <a:ext uri="{FF2B5EF4-FFF2-40B4-BE49-F238E27FC236}">
+                <a16:creationId xmlns:a16="http://schemas.microsoft.com/office/drawing/2014/main" id="{BB3A50C3-5087-571C-2ABD-4B3A5D32915B}"/>
+              </a:ext>
+            </a:extLst>
+          </p:cNvPr>
+          <p:cNvPicPr>
+            <a:picLocks noChangeAspect="1"/>
+          </p:cNvPicPr>
+          <p:nvPr/>
+        </p:nvPicPr>
+        <p:blipFill>
+          <a:blip r:embed="rId3">
+            <a:extLst>
+              <a:ext uri="{28A0092B-C50C-407E-A947-70E740481C1C}">
+                <a14:useLocalDpi xmlns:a14="http://schemas.microsoft.com/office/drawing/2010/main" val="0"/>
+              </a:ext>
+            </a:extLst>
+          </a:blip>
+          <a:stretch>
+            <a:fillRect/>
+          </a:stretch>
+        </p:blipFill>
+        <p:spPr>
+          <a:xfrm>
+            <a:off x="634999" y="3047776"/>
+            <a:ext cx="10922000" cy="3134564"/>
+          </a:xfrm>
+          <a:prstGeom prst="rect">
+            <a:avLst/>
+          </a:prstGeom>
+        </p:spPr>
+      </p:pic>
+      <p:sp>
+        <p:nvSpPr>
+          <p:cNvPr id="8" name="CaixaDeTexto 7">
+            <a:extLst>
+              <a:ext uri="{FF2B5EF4-FFF2-40B4-BE49-F238E27FC236}">
+                <a16:creationId xmlns:a16="http://schemas.microsoft.com/office/drawing/2014/main" id="{EB414AAA-E5F4-009F-F888-A1429B146186}"/>
+              </a:ext>
+            </a:extLst>
+          </p:cNvPr>
+          <p:cNvSpPr txBox="1"/>
+          <p:nvPr/>
+        </p:nvSpPr>
+        <p:spPr>
+          <a:xfrm>
+            <a:off x="6247376" y="1168400"/>
+            <a:ext cx="5309623" cy="1290097"/>
+          </a:xfrm>
+          <a:prstGeom prst="rect">
+            <a:avLst/>
+          </a:prstGeom>
+          <a:noFill/>
+        </p:spPr>
+        <p:txBody>
+          <a:bodyPr wrap="square">
+            <a:spAutoFit/>
+          </a:bodyPr>
+          <a:lstStyle/>
           <a:p>
             <a:pPr marL="342900" indent="-342900">
               <a:spcAft>
@@ -11982,7 +11799,7 @@
               <a:buChar char="•"/>
             </a:pPr>
             <a:r>
-              <a:rPr lang="pt-BR">
+              <a:rPr lang="pt-BR" dirty="0">
                 <a:solidFill>
                   <a:srgbClr val="1E2227"/>
                 </a:solidFill>
@@ -12000,53 +11817,26 @@
               <a:buChar char="•"/>
             </a:pPr>
             <a:r>
-              <a:rPr lang="pt-BR">
+              <a:rPr lang="pt-BR" dirty="0" err="1">
                 <a:solidFill>
                   <a:srgbClr val="1E2227"/>
                 </a:solidFill>
                 <a:latin typeface="Aptos" panose="020B0004020202020204" pitchFamily="34" charset="0"/>
               </a:rPr>
-              <a:t>Silhouette Score: 0,1520, positivo mas com sobreposição natural</a:t>
-            </a:r>
-          </a:p>
-        </p:txBody>
-      </p:sp>
-      <p:pic>
-        <p:nvPicPr>
-          <p:cNvPr id="7" name="Imagem 6">
-            <a:extLst>
-              <a:ext uri="{FF2B5EF4-FFF2-40B4-BE49-F238E27FC236}">
-                <a16:creationId xmlns:a16="http://schemas.microsoft.com/office/drawing/2014/main" id="{BB3A50C3-5087-571C-2ABD-4B3A5D32915B}"/>
-              </a:ext>
-            </a:extLst>
-          </p:cNvPr>
-          <p:cNvPicPr>
-            <a:picLocks noChangeAspect="1"/>
-          </p:cNvPicPr>
-          <p:nvPr/>
-        </p:nvPicPr>
-        <p:blipFill>
-          <a:blip r:embed="rId3">
-            <a:extLst>
-              <a:ext uri="{28A0092B-C50C-407E-A947-70E740481C1C}">
-                <a14:useLocalDpi xmlns:a14="http://schemas.microsoft.com/office/drawing/2010/main" val="0"/>
-              </a:ext>
-            </a:extLst>
-          </a:blip>
-          <a:stretch>
-            <a:fillRect/>
-          </a:stretch>
-        </p:blipFill>
-        <p:spPr>
-          <a:xfrm>
-            <a:off x="7508709" y="2720059"/>
-            <a:ext cx="2064081" cy="592382"/>
-          </a:xfrm>
-          <a:prstGeom prst="rect">
-            <a:avLst/>
-          </a:prstGeom>
-        </p:spPr>
-      </p:pic>
+              <a:t>Silhouette</a:t>
+            </a:r>
+            <a:r>
+              <a:rPr lang="pt-BR" dirty="0">
+                <a:solidFill>
+                  <a:srgbClr val="1E2227"/>
+                </a:solidFill>
+                <a:latin typeface="Aptos" panose="020B0004020202020204" pitchFamily="34" charset="0"/>
+              </a:rPr>
+              <a:t> Score: 0,1520, positivo mas com sobreposição natural</a:t>
+            </a:r>
+          </a:p>
+        </p:txBody>
+      </p:sp>
     </p:spTree>
     <p:extLst>
       <p:ext uri="{BB962C8B-B14F-4D97-AF65-F5344CB8AC3E}">
@@ -12249,7 +12039,7 @@
         <p:spPr>
           <a:xfrm>
             <a:off x="698500" y="1168400"/>
-            <a:ext cx="5016500" cy="2626360"/>
+            <a:ext cx="5016500" cy="1615827"/>
           </a:xfrm>
           <a:prstGeom prst="rect">
             <a:avLst/>
@@ -12270,13 +12060,58 @@
               <a:buChar char="•"/>
             </a:pPr>
             <a:r>
-              <a:rPr lang="pt-BR">
+              <a:rPr lang="pt-BR" dirty="0" err="1">
                 <a:solidFill>
                   <a:srgbClr val="1E2227"/>
                 </a:solidFill>
                 <a:latin typeface="Aptos" panose="020B0004020202020204" pitchFamily="34" charset="0"/>
               </a:rPr>
-              <a:t>Apriori exigiu binarização em tags interpretáveis</a:t>
+              <a:t>Apriori</a:t>
+            </a:r>
+            <a:r>
+              <a:rPr lang="pt-BR" dirty="0">
+                <a:solidFill>
+                  <a:srgbClr val="1E2227"/>
+                </a:solidFill>
+                <a:latin typeface="Aptos" panose="020B0004020202020204" pitchFamily="34" charset="0"/>
+              </a:rPr>
+              <a:t> exigiu </a:t>
+            </a:r>
+            <a:r>
+              <a:rPr lang="pt-BR" dirty="0" err="1">
+                <a:solidFill>
+                  <a:srgbClr val="1E2227"/>
+                </a:solidFill>
+                <a:latin typeface="Aptos" panose="020B0004020202020204" pitchFamily="34" charset="0"/>
+              </a:rPr>
+              <a:t>binarização</a:t>
+            </a:r>
+            <a:r>
+              <a:rPr lang="pt-BR" dirty="0">
+                <a:solidFill>
+                  <a:srgbClr val="1E2227"/>
+                </a:solidFill>
+                <a:latin typeface="Aptos" panose="020B0004020202020204" pitchFamily="34" charset="0"/>
+              </a:rPr>
+              <a:t> em </a:t>
+            </a:r>
+            <a:r>
+              <a:rPr lang="pt-BR" dirty="0" err="1">
+                <a:solidFill>
+                  <a:srgbClr val="1E2227"/>
+                </a:solidFill>
+                <a:latin typeface="Aptos" panose="020B0004020202020204" pitchFamily="34" charset="0"/>
+              </a:rPr>
+              <a:t>tags</a:t>
+            </a:r>
+            <a:r>
+              <a:rPr lang="pt-BR" dirty="0">
+                <a:solidFill>
+                  <a:srgbClr val="1E2227"/>
+                </a:solidFill>
+                <a:latin typeface="Aptos" panose="020B0004020202020204" pitchFamily="34" charset="0"/>
+              </a:rPr>
+              <a:t> interpretáveis</a:t>
             </a:r>
           </a:p>
           <a:p>
@@ -12288,14 +12123,29 @@
               <a:buChar char="•"/>
             </a:pPr>
             <a:r>
-              <a:rPr lang="pt-BR">
+              <a:rPr lang="pt-BR" dirty="0">
                 <a:solidFill>
                   <a:srgbClr val="1E2227"/>
                 </a:solidFill>
                 <a:latin typeface="Aptos" panose="020B0004020202020204" pitchFamily="34" charset="0"/>
               </a:rPr>
-              <a:t>Regras avaliadas por suporte, confiança e lift</a:t>
-            </a:r>
+              <a:t>Regras avaliadas por suporte, confiança e </a:t>
+            </a:r>
+            <a:r>
+              <a:rPr lang="pt-BR" dirty="0" err="1">
+                <a:solidFill>
+                  <a:srgbClr val="1E2227"/>
+                </a:solidFill>
+                <a:latin typeface="Aptos" panose="020B0004020202020204" pitchFamily="34" charset="0"/>
+              </a:rPr>
+              <a:t>lift</a:t>
+            </a:r>
+            <a:endParaRPr lang="pt-BR" dirty="0">
+              <a:solidFill>
+                <a:srgbClr val="1E2227"/>
+              </a:solidFill>
+              <a:latin typeface="Aptos" panose="020B0004020202020204" pitchFamily="34" charset="0"/>
+            </a:endParaRPr>
           </a:p>
           <a:p>
             <a:pPr marL="342900" indent="-342900">
@@ -12306,7 +12156,7 @@
               <a:buChar char="•"/>
             </a:pPr>
             <a:r>
-              <a:rPr lang="pt-BR">
+              <a:rPr lang="pt-BR" dirty="0">
                 <a:solidFill>
                   <a:srgbClr val="1E2227"/>
                 </a:solidFill>
@@ -12315,6 +12165,71 @@
               <a:t>Associações fortes envolvem casas grandes, bairros premium e garagens maiores</a:t>
             </a:r>
           </a:p>
+        </p:txBody>
+      </p:sp>
+      <p:pic>
+        <p:nvPicPr>
+          <p:cNvPr id="7" name="Imagem 6">
+            <a:extLst>
+              <a:ext uri="{FF2B5EF4-FFF2-40B4-BE49-F238E27FC236}">
+                <a16:creationId xmlns:a16="http://schemas.microsoft.com/office/drawing/2014/main" id="{FD963736-6F79-0DED-8B6A-7FF98787C6CF}"/>
+              </a:ext>
+            </a:extLst>
+          </p:cNvPr>
+          <p:cNvPicPr>
+            <a:picLocks noChangeAspect="1"/>
+          </p:cNvPicPr>
+          <p:nvPr/>
+        </p:nvPicPr>
+        <p:blipFill>
+          <a:blip r:embed="rId3">
+            <a:extLst>
+              <a:ext uri="{28A0092B-C50C-407E-A947-70E740481C1C}">
+                <a14:useLocalDpi xmlns:a14="http://schemas.microsoft.com/office/drawing/2010/main" val="0"/>
+              </a:ext>
+            </a:extLst>
+          </a:blip>
+          <a:stretch>
+            <a:fillRect/>
+          </a:stretch>
+        </p:blipFill>
+        <p:spPr>
+          <a:xfrm>
+            <a:off x="1683027" y="3097449"/>
+            <a:ext cx="8921558" cy="3456774"/>
+          </a:xfrm>
+          <a:prstGeom prst="rect">
+            <a:avLst/>
+          </a:prstGeom>
+        </p:spPr>
+      </p:pic>
+      <p:sp>
+        <p:nvSpPr>
+          <p:cNvPr id="8" name="CaixaDeTexto 7">
+            <a:extLst>
+              <a:ext uri="{FF2B5EF4-FFF2-40B4-BE49-F238E27FC236}">
+                <a16:creationId xmlns:a16="http://schemas.microsoft.com/office/drawing/2014/main" id="{40E5C67B-0F1B-0AC5-7A28-3080A7F74780}"/>
+              </a:ext>
+            </a:extLst>
+          </p:cNvPr>
+          <p:cNvSpPr txBox="1"/>
+          <p:nvPr/>
+        </p:nvSpPr>
+        <p:spPr>
+          <a:xfrm>
+            <a:off x="6477002" y="1240214"/>
+            <a:ext cx="6097022" cy="736099"/>
+          </a:xfrm>
+          <a:prstGeom prst="rect">
+            <a:avLst/>
+          </a:prstGeom>
+          <a:noFill/>
+        </p:spPr>
+        <p:txBody>
+          <a:bodyPr wrap="square">
+            <a:spAutoFit/>
+          </a:bodyPr>
+          <a:lstStyle/>
           <a:p>
             <a:pPr marL="342900" indent="-342900">
               <a:spcAft>
@@ -12324,7 +12239,7 @@
               <a:buChar char="•"/>
             </a:pPr>
             <a:r>
-              <a:rPr lang="pt-BR">
+              <a:rPr lang="pt-BR" dirty="0">
                 <a:solidFill>
                   <a:srgbClr val="1E2227"/>
                 </a:solidFill>
@@ -12342,7 +12257,7 @@
               <a:buChar char="•"/>
             </a:pPr>
             <a:r>
-              <a:rPr lang="pt-BR">
+              <a:rPr lang="pt-BR" dirty="0">
                 <a:solidFill>
                   <a:srgbClr val="1E2227"/>
                 </a:solidFill>
@@ -12353,42 +12268,6 @@
           </a:p>
         </p:txBody>
       </p:sp>
-      <p:pic>
-        <p:nvPicPr>
-          <p:cNvPr id="7" name="Imagem 6">
-            <a:extLst>
-              <a:ext uri="{FF2B5EF4-FFF2-40B4-BE49-F238E27FC236}">
-                <a16:creationId xmlns:a16="http://schemas.microsoft.com/office/drawing/2014/main" id="{FD963736-6F79-0DED-8B6A-7FF98787C6CF}"/>
-              </a:ext>
-            </a:extLst>
-          </p:cNvPr>
-          <p:cNvPicPr>
-            <a:picLocks noChangeAspect="1"/>
-          </p:cNvPicPr>
-          <p:nvPr/>
-        </p:nvPicPr>
-        <p:blipFill>
-          <a:blip r:embed="rId3">
-            <a:extLst>
-              <a:ext uri="{28A0092B-C50C-407E-A947-70E740481C1C}">
-                <a14:useLocalDpi xmlns:a14="http://schemas.microsoft.com/office/drawing/2010/main" val="0"/>
-              </a:ext>
-            </a:extLst>
-          </a:blip>
-          <a:stretch>
-            <a:fillRect/>
-          </a:stretch>
-        </p:blipFill>
-        <p:spPr>
-          <a:xfrm>
-            <a:off x="7680854" y="2646166"/>
-            <a:ext cx="1910293" cy="740168"/>
-          </a:xfrm>
-          <a:prstGeom prst="rect">
-            <a:avLst/>
-          </a:prstGeom>
-        </p:spPr>
-      </p:pic>
     </p:spTree>
     <p:extLst>
       <p:ext uri="{BB962C8B-B14F-4D97-AF65-F5344CB8AC3E}">

</xml_diff>